<commit_message>
new word file added
</commit_message>
<xml_diff>
--- a/15/Potfolio_report.pptx
+++ b/15/Potfolio_report.pptx
@@ -511,7 +511,7 @@
             <a:pPr>
               <a:defRPr/>
             </a:pPr>
-            <a:fld id="{344DE016-8493-EC63-1394-EAA0CA000FF6}" type="slidenum">
+            <a:fld id="{F0D6E705-0F09-58D6-FAD8-0222D928EA0D}" type="slidenum">
               <a:rPr/>
               <a:t/>
             </a:fld>
@@ -1566,7 +1566,7 @@
       </p:grpSpPr>
       <p:sp>
         <p:nvSpPr>
-          <p:cNvPr id="977669362" name="Title 1"/>
+          <p:cNvPr id="890002461" name="Title 1"/>
           <p:cNvSpPr>
             <a:spLocks noGrp="1"/>
           </p:cNvSpPr>
@@ -1601,7 +1601,7 @@
       </p:sp>
       <p:sp>
         <p:nvSpPr>
-          <p:cNvPr id="504567466" name="Subtitle 2"/>
+          <p:cNvPr id="26864472" name="Subtitle 2"/>
           <p:cNvSpPr>
             <a:spLocks noGrp="1"/>
           </p:cNvSpPr>
@@ -1723,7 +1723,7 @@
       </p:sp>
       <p:sp>
         <p:nvSpPr>
-          <p:cNvPr id="1910768708" name="Date Placeholder 3"/>
+          <p:cNvPr id="1125359192" name="Date Placeholder 3"/>
           <p:cNvSpPr>
             <a:spLocks noGrp="1"/>
           </p:cNvSpPr>
@@ -1749,7 +1749,7 @@
       </p:sp>
       <p:sp>
         <p:nvSpPr>
-          <p:cNvPr id="155866329" name="Footer Placeholder 4"/>
+          <p:cNvPr id="1186885780" name="Footer Placeholder 4"/>
           <p:cNvSpPr>
             <a:spLocks noGrp="1"/>
           </p:cNvSpPr>
@@ -1771,7 +1771,7 @@
       </p:sp>
       <p:sp>
         <p:nvSpPr>
-          <p:cNvPr id="230501318" name="Slide Number Placeholder 5"/>
+          <p:cNvPr id="1926566120" name="Slide Number Placeholder 5"/>
           <p:cNvSpPr>
             <a:spLocks noGrp="1"/>
           </p:cNvSpPr>
@@ -1822,7 +1822,7 @@
       </p:grpSpPr>
       <p:sp>
         <p:nvSpPr>
-          <p:cNvPr id="143174926" name="Title 1"/>
+          <p:cNvPr id="1797755622" name="Title 1"/>
           <p:cNvSpPr>
             <a:spLocks noGrp="1"/>
           </p:cNvSpPr>
@@ -1848,7 +1848,7 @@
       </p:sp>
       <p:sp>
         <p:nvSpPr>
-          <p:cNvPr id="1639432327" name="Vertical Text Placeholder 2"/>
+          <p:cNvPr id="263725289" name="Vertical Text Placeholder 2"/>
           <p:cNvSpPr>
             <a:spLocks noGrp="1"/>
           </p:cNvSpPr>
@@ -1914,7 +1914,7 @@
       </p:sp>
       <p:sp>
         <p:nvSpPr>
-          <p:cNvPr id="1524400742" name="Date Placeholder 3"/>
+          <p:cNvPr id="623890232" name="Date Placeholder 3"/>
           <p:cNvSpPr>
             <a:spLocks noGrp="1"/>
           </p:cNvSpPr>
@@ -1940,7 +1940,7 @@
       </p:sp>
       <p:sp>
         <p:nvSpPr>
-          <p:cNvPr id="658058742" name="Footer Placeholder 4"/>
+          <p:cNvPr id="755630504" name="Footer Placeholder 4"/>
           <p:cNvSpPr>
             <a:spLocks noGrp="1"/>
           </p:cNvSpPr>
@@ -1962,7 +1962,7 @@
       </p:sp>
       <p:sp>
         <p:nvSpPr>
-          <p:cNvPr id="351051057" name="Slide Number Placeholder 5"/>
+          <p:cNvPr id="987325016" name="Slide Number Placeholder 5"/>
           <p:cNvSpPr>
             <a:spLocks noGrp="1"/>
           </p:cNvSpPr>
@@ -2013,7 +2013,7 @@
       </p:grpSpPr>
       <p:sp>
         <p:nvSpPr>
-          <p:cNvPr id="1029559226" name="Vertical Title 1"/>
+          <p:cNvPr id="1243530900" name="Vertical Title 1"/>
           <p:cNvSpPr>
             <a:spLocks noGrp="1"/>
           </p:cNvSpPr>
@@ -2048,7 +2048,7 @@
       </p:sp>
       <p:sp>
         <p:nvSpPr>
-          <p:cNvPr id="118790176" name="Vertical Text Placeholder 2"/>
+          <p:cNvPr id="1837546457" name="Vertical Text Placeholder 2"/>
           <p:cNvSpPr>
             <a:spLocks noGrp="1"/>
           </p:cNvSpPr>
@@ -2119,7 +2119,7 @@
       </p:sp>
       <p:sp>
         <p:nvSpPr>
-          <p:cNvPr id="1085206486" name="Date Placeholder 3"/>
+          <p:cNvPr id="1446578497" name="Date Placeholder 3"/>
           <p:cNvSpPr>
             <a:spLocks noGrp="1"/>
           </p:cNvSpPr>
@@ -2145,7 +2145,7 @@
       </p:sp>
       <p:sp>
         <p:nvSpPr>
-          <p:cNvPr id="718752139" name="Footer Placeholder 4"/>
+          <p:cNvPr id="742238976" name="Footer Placeholder 4"/>
           <p:cNvSpPr>
             <a:spLocks noGrp="1"/>
           </p:cNvSpPr>
@@ -2167,7 +2167,7 @@
       </p:sp>
       <p:sp>
         <p:nvSpPr>
-          <p:cNvPr id="2037949238" name="Slide Number Placeholder 5"/>
+          <p:cNvPr id="1809991255" name="Slide Number Placeholder 5"/>
           <p:cNvSpPr>
             <a:spLocks noGrp="1"/>
           </p:cNvSpPr>
@@ -2218,7 +2218,7 @@
       </p:grpSpPr>
       <p:sp>
         <p:nvSpPr>
-          <p:cNvPr id="452980745" name="Title 1"/>
+          <p:cNvPr id="935623314" name="Title 1"/>
           <p:cNvSpPr>
             <a:spLocks noGrp="1"/>
           </p:cNvSpPr>
@@ -2244,7 +2244,7 @@
       </p:sp>
       <p:sp>
         <p:nvSpPr>
-          <p:cNvPr id="1870040162" name="Content Placeholder 2"/>
+          <p:cNvPr id="754027091" name="Content Placeholder 2"/>
           <p:cNvSpPr>
             <a:spLocks noGrp="1"/>
           </p:cNvSpPr>
@@ -2310,7 +2310,7 @@
       </p:sp>
       <p:sp>
         <p:nvSpPr>
-          <p:cNvPr id="1919893105" name="Date Placeholder 3"/>
+          <p:cNvPr id="1812226912" name="Date Placeholder 3"/>
           <p:cNvSpPr>
             <a:spLocks noGrp="1"/>
           </p:cNvSpPr>
@@ -2336,7 +2336,7 @@
       </p:sp>
       <p:sp>
         <p:nvSpPr>
-          <p:cNvPr id="1872342663" name="Footer Placeholder 4"/>
+          <p:cNvPr id="1922559057" name="Footer Placeholder 4"/>
           <p:cNvSpPr>
             <a:spLocks noGrp="1"/>
           </p:cNvSpPr>
@@ -2358,7 +2358,7 @@
       </p:sp>
       <p:sp>
         <p:nvSpPr>
-          <p:cNvPr id="1359082252" name="Slide Number Placeholder 5"/>
+          <p:cNvPr id="1227091694" name="Slide Number Placeholder 5"/>
           <p:cNvSpPr>
             <a:spLocks noGrp="1"/>
           </p:cNvSpPr>
@@ -2409,7 +2409,7 @@
       </p:grpSpPr>
       <p:sp>
         <p:nvSpPr>
-          <p:cNvPr id="703089225" name="Title 1"/>
+          <p:cNvPr id="1592425765" name="Title 1"/>
           <p:cNvSpPr>
             <a:spLocks noGrp="1"/>
           </p:cNvSpPr>
@@ -2444,7 +2444,7 @@
       </p:sp>
       <p:sp>
         <p:nvSpPr>
-          <p:cNvPr id="137041336" name="Text Placeholder 2"/>
+          <p:cNvPr id="136203860" name="Text Placeholder 2"/>
           <p:cNvSpPr>
             <a:spLocks noGrp="1"/>
           </p:cNvSpPr>
@@ -2566,7 +2566,7 @@
       </p:sp>
       <p:sp>
         <p:nvSpPr>
-          <p:cNvPr id="1531007293" name="Date Placeholder 3"/>
+          <p:cNvPr id="585097450" name="Date Placeholder 3"/>
           <p:cNvSpPr>
             <a:spLocks noGrp="1"/>
           </p:cNvSpPr>
@@ -2592,7 +2592,7 @@
       </p:sp>
       <p:sp>
         <p:nvSpPr>
-          <p:cNvPr id="1863640452" name="Footer Placeholder 4"/>
+          <p:cNvPr id="1026026669" name="Footer Placeholder 4"/>
           <p:cNvSpPr>
             <a:spLocks noGrp="1"/>
           </p:cNvSpPr>
@@ -2614,7 +2614,7 @@
       </p:sp>
       <p:sp>
         <p:nvSpPr>
-          <p:cNvPr id="2054541725" name="Slide Number Placeholder 5"/>
+          <p:cNvPr id="1172983745" name="Slide Number Placeholder 5"/>
           <p:cNvSpPr>
             <a:spLocks noGrp="1"/>
           </p:cNvSpPr>
@@ -2665,7 +2665,7 @@
       </p:grpSpPr>
       <p:sp>
         <p:nvSpPr>
-          <p:cNvPr id="614750196" name="Title 1"/>
+          <p:cNvPr id="1258352605" name="Title 1"/>
           <p:cNvSpPr>
             <a:spLocks noGrp="1"/>
           </p:cNvSpPr>
@@ -2691,7 +2691,7 @@
       </p:sp>
       <p:sp>
         <p:nvSpPr>
-          <p:cNvPr id="1563643544" name="Content Placeholder 2"/>
+          <p:cNvPr id="187991055" name="Content Placeholder 2"/>
           <p:cNvSpPr>
             <a:spLocks noGrp="1"/>
           </p:cNvSpPr>
@@ -2790,7 +2790,7 @@
       </p:sp>
       <p:sp>
         <p:nvSpPr>
-          <p:cNvPr id="1798089633" name="Content Placeholder 3"/>
+          <p:cNvPr id="1575658" name="Content Placeholder 3"/>
           <p:cNvSpPr>
             <a:spLocks noGrp="1"/>
           </p:cNvSpPr>
@@ -2889,7 +2889,7 @@
       </p:sp>
       <p:sp>
         <p:nvSpPr>
-          <p:cNvPr id="539309913" name="Date Placeholder 4"/>
+          <p:cNvPr id="1328153116" name="Date Placeholder 4"/>
           <p:cNvSpPr>
             <a:spLocks noGrp="1"/>
           </p:cNvSpPr>
@@ -2915,7 +2915,7 @@
       </p:sp>
       <p:sp>
         <p:nvSpPr>
-          <p:cNvPr id="528533649" name="Footer Placeholder 5"/>
+          <p:cNvPr id="1210968405" name="Footer Placeholder 5"/>
           <p:cNvSpPr>
             <a:spLocks noGrp="1"/>
           </p:cNvSpPr>
@@ -2937,7 +2937,7 @@
       </p:sp>
       <p:sp>
         <p:nvSpPr>
-          <p:cNvPr id="1765570968" name="Slide Number Placeholder 6"/>
+          <p:cNvPr id="1315088892" name="Slide Number Placeholder 6"/>
           <p:cNvSpPr>
             <a:spLocks noGrp="1"/>
           </p:cNvSpPr>
@@ -2988,7 +2988,7 @@
       </p:grpSpPr>
       <p:sp>
         <p:nvSpPr>
-          <p:cNvPr id="1664543617" name="Title 1"/>
+          <p:cNvPr id="2097924099" name="Title 1"/>
           <p:cNvSpPr>
             <a:spLocks noGrp="1"/>
           </p:cNvSpPr>
@@ -3018,7 +3018,7 @@
       </p:sp>
       <p:sp>
         <p:nvSpPr>
-          <p:cNvPr id="1282092377" name="Text Placeholder 2"/>
+          <p:cNvPr id="348172878" name="Text Placeholder 2"/>
           <p:cNvSpPr>
             <a:spLocks noGrp="1"/>
           </p:cNvSpPr>
@@ -3086,7 +3086,7 @@
       </p:sp>
       <p:sp>
         <p:nvSpPr>
-          <p:cNvPr id="447777886" name="Content Placeholder 3"/>
+          <p:cNvPr id="969304658" name="Content Placeholder 3"/>
           <p:cNvSpPr>
             <a:spLocks noGrp="1"/>
           </p:cNvSpPr>
@@ -3185,7 +3185,7 @@
       </p:sp>
       <p:sp>
         <p:nvSpPr>
-          <p:cNvPr id="1870859544" name="Text Placeholder 4"/>
+          <p:cNvPr id="2011378636" name="Text Placeholder 4"/>
           <p:cNvSpPr>
             <a:spLocks noGrp="1"/>
           </p:cNvSpPr>
@@ -3253,7 +3253,7 @@
       </p:sp>
       <p:sp>
         <p:nvSpPr>
-          <p:cNvPr id="601875046" name="Content Placeholder 5"/>
+          <p:cNvPr id="1801548692" name="Content Placeholder 5"/>
           <p:cNvSpPr>
             <a:spLocks noGrp="1"/>
           </p:cNvSpPr>
@@ -3352,7 +3352,7 @@
       </p:sp>
       <p:sp>
         <p:nvSpPr>
-          <p:cNvPr id="1783200693" name="Date Placeholder 6"/>
+          <p:cNvPr id="1533577972" name="Date Placeholder 6"/>
           <p:cNvSpPr>
             <a:spLocks noGrp="1"/>
           </p:cNvSpPr>
@@ -3378,7 +3378,7 @@
       </p:sp>
       <p:sp>
         <p:nvSpPr>
-          <p:cNvPr id="1896605574" name="Footer Placeholder 7"/>
+          <p:cNvPr id="1526640924" name="Footer Placeholder 7"/>
           <p:cNvSpPr>
             <a:spLocks noGrp="1"/>
           </p:cNvSpPr>
@@ -3400,7 +3400,7 @@
       </p:sp>
       <p:sp>
         <p:nvSpPr>
-          <p:cNvPr id="600987771" name="Slide Number Placeholder 8"/>
+          <p:cNvPr id="128479906" name="Slide Number Placeholder 8"/>
           <p:cNvSpPr>
             <a:spLocks noGrp="1"/>
           </p:cNvSpPr>
@@ -3451,7 +3451,7 @@
       </p:grpSpPr>
       <p:sp>
         <p:nvSpPr>
-          <p:cNvPr id="985928400" name="Title 1"/>
+          <p:cNvPr id="338614495" name="Title 1"/>
           <p:cNvSpPr>
             <a:spLocks noGrp="1"/>
           </p:cNvSpPr>
@@ -3477,7 +3477,7 @@
       </p:sp>
       <p:sp>
         <p:nvSpPr>
-          <p:cNvPr id="643544193" name="Date Placeholder 2"/>
+          <p:cNvPr id="1734651603" name="Date Placeholder 2"/>
           <p:cNvSpPr>
             <a:spLocks noGrp="1"/>
           </p:cNvSpPr>
@@ -3503,7 +3503,7 @@
       </p:sp>
       <p:sp>
         <p:nvSpPr>
-          <p:cNvPr id="1556035883" name="Footer Placeholder 3"/>
+          <p:cNvPr id="1744610445" name="Footer Placeholder 3"/>
           <p:cNvSpPr>
             <a:spLocks noGrp="1"/>
           </p:cNvSpPr>
@@ -3525,7 +3525,7 @@
       </p:sp>
       <p:sp>
         <p:nvSpPr>
-          <p:cNvPr id="2052212598" name="Slide Number Placeholder 4"/>
+          <p:cNvPr id="523940603" name="Slide Number Placeholder 4"/>
           <p:cNvSpPr>
             <a:spLocks noGrp="1"/>
           </p:cNvSpPr>
@@ -3576,7 +3576,7 @@
       </p:grpSpPr>
       <p:sp>
         <p:nvSpPr>
-          <p:cNvPr id="976355068" name="Date Placeholder 1"/>
+          <p:cNvPr id="1288872174" name="Date Placeholder 1"/>
           <p:cNvSpPr>
             <a:spLocks noGrp="1"/>
           </p:cNvSpPr>
@@ -3602,7 +3602,7 @@
       </p:sp>
       <p:sp>
         <p:nvSpPr>
-          <p:cNvPr id="1835623771" name="Footer Placeholder 2"/>
+          <p:cNvPr id="1247206641" name="Footer Placeholder 2"/>
           <p:cNvSpPr>
             <a:spLocks noGrp="1"/>
           </p:cNvSpPr>
@@ -3624,7 +3624,7 @@
       </p:sp>
       <p:sp>
         <p:nvSpPr>
-          <p:cNvPr id="815409454" name="Slide Number Placeholder 3"/>
+          <p:cNvPr id="668497996" name="Slide Number Placeholder 3"/>
           <p:cNvSpPr>
             <a:spLocks noGrp="1"/>
           </p:cNvSpPr>
@@ -3675,7 +3675,7 @@
       </p:grpSpPr>
       <p:sp>
         <p:nvSpPr>
-          <p:cNvPr id="1181112854" name="Title 1"/>
+          <p:cNvPr id="445531579" name="Title 1"/>
           <p:cNvSpPr>
             <a:spLocks noGrp="1"/>
           </p:cNvSpPr>
@@ -3710,7 +3710,7 @@
       </p:sp>
       <p:sp>
         <p:nvSpPr>
-          <p:cNvPr id="1585706912" name="Content Placeholder 2"/>
+          <p:cNvPr id="150031892" name="Content Placeholder 2"/>
           <p:cNvSpPr>
             <a:spLocks noGrp="1"/>
           </p:cNvSpPr>
@@ -3809,7 +3809,7 @@
       </p:sp>
       <p:sp>
         <p:nvSpPr>
-          <p:cNvPr id="509940234" name="Text Placeholder 3"/>
+          <p:cNvPr id="908334597" name="Text Placeholder 3"/>
           <p:cNvSpPr>
             <a:spLocks noGrp="1"/>
           </p:cNvSpPr>
@@ -3877,7 +3877,7 @@
       </p:sp>
       <p:sp>
         <p:nvSpPr>
-          <p:cNvPr id="742427208" name="Date Placeholder 4"/>
+          <p:cNvPr id="1112480833" name="Date Placeholder 4"/>
           <p:cNvSpPr>
             <a:spLocks noGrp="1"/>
           </p:cNvSpPr>
@@ -3903,7 +3903,7 @@
       </p:sp>
       <p:sp>
         <p:nvSpPr>
-          <p:cNvPr id="198424056" name="Footer Placeholder 5"/>
+          <p:cNvPr id="803406407" name="Footer Placeholder 5"/>
           <p:cNvSpPr>
             <a:spLocks noGrp="1"/>
           </p:cNvSpPr>
@@ -3925,7 +3925,7 @@
       </p:sp>
       <p:sp>
         <p:nvSpPr>
-          <p:cNvPr id="662299127" name="Slide Number Placeholder 6"/>
+          <p:cNvPr id="929974754" name="Slide Number Placeholder 6"/>
           <p:cNvSpPr>
             <a:spLocks noGrp="1"/>
           </p:cNvSpPr>
@@ -3976,7 +3976,7 @@
       </p:grpSpPr>
       <p:sp>
         <p:nvSpPr>
-          <p:cNvPr id="162688187" name="Title 1"/>
+          <p:cNvPr id="254013770" name="Title 1"/>
           <p:cNvSpPr>
             <a:spLocks noGrp="1"/>
           </p:cNvSpPr>
@@ -4011,7 +4011,7 @@
       </p:sp>
       <p:sp>
         <p:nvSpPr>
-          <p:cNvPr id="461978937" name="Picture Placeholder 2"/>
+          <p:cNvPr id="251455559" name="Picture Placeholder 2"/>
           <p:cNvSpPr>
             <a:spLocks noGrp="1"/>
           </p:cNvSpPr>
@@ -4075,7 +4075,7 @@
       </p:sp>
       <p:sp>
         <p:nvSpPr>
-          <p:cNvPr id="848714717" name="Text Placeholder 3"/>
+          <p:cNvPr id="915524302" name="Text Placeholder 3"/>
           <p:cNvSpPr>
             <a:spLocks noGrp="1"/>
           </p:cNvSpPr>
@@ -4143,7 +4143,7 @@
       </p:sp>
       <p:sp>
         <p:nvSpPr>
-          <p:cNvPr id="1674013604" name="Date Placeholder 4"/>
+          <p:cNvPr id="2067347123" name="Date Placeholder 4"/>
           <p:cNvSpPr>
             <a:spLocks noGrp="1"/>
           </p:cNvSpPr>
@@ -4169,7 +4169,7 @@
       </p:sp>
       <p:sp>
         <p:nvSpPr>
-          <p:cNvPr id="1873035455" name="Footer Placeholder 5"/>
+          <p:cNvPr id="910978036" name="Footer Placeholder 5"/>
           <p:cNvSpPr>
             <a:spLocks noGrp="1"/>
           </p:cNvSpPr>
@@ -4191,7 +4191,7 @@
       </p:sp>
       <p:sp>
         <p:nvSpPr>
-          <p:cNvPr id="1241725229" name="Slide Number Placeholder 6"/>
+          <p:cNvPr id="1064939407" name="Slide Number Placeholder 6"/>
           <p:cNvSpPr>
             <a:spLocks noGrp="1"/>
           </p:cNvSpPr>
@@ -4247,7 +4247,7 @@
       </p:grpSpPr>
       <p:sp>
         <p:nvSpPr>
-          <p:cNvPr id="374973641" name="Text Placeholder 2"/>
+          <p:cNvPr id="1443036864" name="Text Placeholder 2"/>
           <p:cNvSpPr>
             <a:spLocks noGrp="1"/>
           </p:cNvSpPr>
@@ -4323,7 +4323,7 @@
       </p:sp>
       <p:sp>
         <p:nvSpPr>
-          <p:cNvPr id="1388003486" name="Shape 1058"/>
+          <p:cNvPr id="1259711949" name="Shape 1058"/>
           <p:cNvSpPr>
             <a:spLocks noChangeArrowheads="1" noGrp="1"/>
           </p:cNvSpPr>
@@ -4400,7 +4400,7 @@
       </p:sp>
       <p:sp>
         <p:nvSpPr>
-          <p:cNvPr id="1700923025" name="Shape 1059"/>
+          <p:cNvPr id="1841968314" name="Shape 1059"/>
           <p:cNvSpPr>
             <a:spLocks noChangeArrowheads="1" noGrp="1"/>
           </p:cNvSpPr>
@@ -4415,7 +4415,7 @@
       </p:sp>
       <p:sp>
         <p:nvSpPr>
-          <p:cNvPr id="708943806" name="Shape 1060"/>
+          <p:cNvPr id="613454026" name="Shape 1060"/>
           <p:cNvSpPr>
             <a:spLocks noChangeArrowheads="1" noGrp="1"/>
           </p:cNvSpPr>
@@ -4512,7 +4512,7 @@
       </p:sp>
       <p:sp>
         <p:nvSpPr>
-          <p:cNvPr id="1507782112" name="Shape 1061"/>
+          <p:cNvPr id="698988942" name="Shape 1061"/>
           <p:cNvSpPr>
             <a:spLocks noChangeArrowheads="1" noGrp="1"/>
           </p:cNvSpPr>
@@ -4609,7 +4609,7 @@
       </p:sp>
       <p:sp>
         <p:nvSpPr>
-          <p:cNvPr id="698542385" name="Shape 1062"/>
+          <p:cNvPr id="666250956" name="Shape 1062"/>
           <p:cNvSpPr>
             <a:spLocks noChangeArrowheads="1" noGrp="1"/>
           </p:cNvSpPr>
@@ -4706,7 +4706,7 @@
       </p:sp>
       <p:sp>
         <p:nvSpPr>
-          <p:cNvPr id="1642275708" name="Shape 1063"/>
+          <p:cNvPr id="1660072204" name="Shape 1063"/>
           <p:cNvSpPr>
             <a:spLocks noChangeArrowheads="1" noGrp="1"/>
           </p:cNvSpPr>
@@ -4803,7 +4803,7 @@
       </p:sp>
       <p:sp>
         <p:nvSpPr>
-          <p:cNvPr id="267730449" name="Shape 1064"/>
+          <p:cNvPr id="421334835" name="Shape 1064"/>
           <p:cNvSpPr>
             <a:spLocks noChangeArrowheads="1" noGrp="1"/>
           </p:cNvSpPr>
@@ -4900,7 +4900,7 @@
       </p:sp>
       <p:sp>
         <p:nvSpPr>
-          <p:cNvPr id="697386014" name="Shape 1065"/>
+          <p:cNvPr id="1231610425" name="Shape 1065"/>
           <p:cNvSpPr>
             <a:spLocks noChangeArrowheads="1" noGrp="1"/>
           </p:cNvSpPr>
@@ -4997,7 +4997,7 @@
       </p:sp>
       <p:sp>
         <p:nvSpPr>
-          <p:cNvPr id="695369755" name="Shape 1066"/>
+          <p:cNvPr id="1306719757" name="Shape 1066"/>
           <p:cNvSpPr>
             <a:spLocks noChangeArrowheads="1" noGrp="1"/>
           </p:cNvSpPr>
@@ -5094,7 +5094,7 @@
       </p:sp>
       <p:sp>
         <p:nvSpPr>
-          <p:cNvPr id="453908190" name="Shape 1067"/>
+          <p:cNvPr id="942918639" name="Shape 1067"/>
           <p:cNvSpPr>
             <a:spLocks noChangeArrowheads="1" noGrp="1"/>
           </p:cNvSpPr>
@@ -5191,7 +5191,7 @@
       </p:sp>
       <p:sp>
         <p:nvSpPr>
-          <p:cNvPr id="1150410875" name="Shape 1068"/>
+          <p:cNvPr id="1590971699" name="Shape 1068"/>
           <p:cNvSpPr>
             <a:spLocks noChangeArrowheads="1" noGrp="1"/>
           </p:cNvSpPr>
@@ -5288,7 +5288,7 @@
       </p:sp>
       <p:sp>
         <p:nvSpPr>
-          <p:cNvPr id="1407316852" name="Shape 1069"/>
+          <p:cNvPr id="1006896558" name="Shape 1069"/>
           <p:cNvSpPr>
             <a:spLocks noChangeArrowheads="1" noGrp="1"/>
           </p:cNvSpPr>
@@ -5385,7 +5385,7 @@
       </p:sp>
       <p:sp>
         <p:nvSpPr>
-          <p:cNvPr id="1811534956" name="Shape 1070"/>
+          <p:cNvPr id="567814509" name="Shape 1070"/>
           <p:cNvSpPr>
             <a:spLocks noChangeArrowheads="1" noGrp="1"/>
           </p:cNvSpPr>
@@ -5480,7 +5480,7 @@
       </p:sp>
       <p:sp>
         <p:nvSpPr>
-          <p:cNvPr id="356945013" name="Title 1"/>
+          <p:cNvPr id="2047839704" name="Title 1"/>
           <p:cNvSpPr>
             <a:spLocks noGrp="1"/>
           </p:cNvSpPr>
@@ -5516,7 +5516,7 @@
       </p:sp>
       <p:sp>
         <p:nvSpPr>
-          <p:cNvPr id="1031908423" name="Slide Number Placeholder 5"/>
+          <p:cNvPr id="430119060" name="Slide Number Placeholder 5"/>
           <p:cNvSpPr>
             <a:spLocks noGrp="1"/>
           </p:cNvSpPr>
@@ -5564,7 +5564,7 @@
       </p:sp>
       <p:sp>
         <p:nvSpPr>
-          <p:cNvPr id="179115365" name="Date Placeholder 3"/>
+          <p:cNvPr id="684124934" name="Date Placeholder 3"/>
           <p:cNvSpPr>
             <a:spLocks noGrp="1"/>
           </p:cNvSpPr>
@@ -5608,7 +5608,7 @@
       </p:sp>
       <p:sp>
         <p:nvSpPr>
-          <p:cNvPr id="511713817" name="Footer Placeholder 4"/>
+          <p:cNvPr id="542080050" name="Footer Placeholder 4"/>
           <p:cNvSpPr>
             <a:spLocks noGrp="1"/>
           </p:cNvSpPr>
@@ -5934,7 +5934,7 @@
       </p:grpSpPr>
       <p:sp>
         <p:nvSpPr>
-          <p:cNvPr id="16234061" name="Title 1"/>
+          <p:cNvPr id="78147540" name="Title 1"/>
           <p:cNvSpPr>
             <a:spLocks noGrp="1"/>
           </p:cNvSpPr>
@@ -5960,7 +5960,7 @@
       </p:sp>
       <p:sp>
         <p:nvSpPr>
-          <p:cNvPr id="1122924447" name="Subtitle 2"/>
+          <p:cNvPr id="1033549531" name="Subtitle 2"/>
           <p:cNvSpPr>
             <a:spLocks noGrp="1"/>
           </p:cNvSpPr>
@@ -7483,7 +7483,7 @@
             </a:pPr>
             <a:r>
               <a:rPr/>
-              <a:t>In the pre-processing new columns were created, img_cont, cont_rating, avg_rating, availability_grouped(encoded, availability column), number_of_clicks (processed breadcrumb column, this helped determine how precise a product was classified.</a:t>
+              <a:t>In the pre-processing new columns were created, img_cont, cont_rating, avg_rating, availability_grouped(encoded, availability column), number_of_clicks (processed breadcrumb column, this helped determine how precise a product was classified, CCV_score (logrithmic value).</a:t>
             </a:r>
             <a:endParaRPr/>
           </a:p>

</xml_diff>